<commit_message>
CIA deck: moderate integrity rating, industry-practice note, TSA source
Co-Authored-By: Claude Opus 5.5 <noreply@anthropic.com>
</commit_message>
<xml_diff>
--- a/module-02-cia-triad-analysis/Ruthvik_Nath_Bandari_Module2_CIA_Triad_Analysis.pptx
+++ b/module-02-cia-triad-analysis/Ruthvik_Nath_Bandari_Module2_CIA_Triad_Analysis.pptx
@@ -648,7 +648,7 @@
           <a:lstStyle/>
           <a:p>
             <a:r>
-              <a:t>This diagram maps the attack onto the triad. The attack vector is the long-running exfiltration in the centre. Confidentiality is severe: more than 153 million identity images were copied and sold. Integrity is high: the stolen scans include the infrared and ultraviolet images that verifiers check, so criminals can make convincing forgeries and open fraudulent accounts, which breaks the trust that a verified ID proves identity. Availability is low: Krebs reports no outage of IDScan's service, but there is indirect loss, because victims must freeze their credit and business clients may have to pause or repeat verification while the vendor investigates.</a:t>
+              <a:t>This diagram maps the attack onto the triad. The attack vector is the long-running exfiltration in the centre. Confidentiality is severe: more than 153 million identity images were copied and sold. Integrity is moderate: Krebs reports no evidence that IDScan's stored records were altered, so the harm is downstream. The stolen scans include the infrared and ultraviolet images that verifiers check, so criminals can make convincing forgeries and open fraudulent accounts elsewhere, which undermines the trust that a verified ID proves identity. Availability is low: Krebs reports no outage of IDScan's service, but there is indirect loss, because victims must freeze their credit and business clients may have to pause or repeat verification while the vendor investigates.</a:t>
             </a:r>
           </a:p>
         </p:txBody>
@@ -858,7 +858,7 @@
           <a:lstStyle/>
           <a:p>
             <a:r>
-              <a:t>The current trend I connect to mitigation is the shift to mobile driver's licenses and selective disclosure, standardised in ISO/IEC 18013-5. Instead of photocopying a physical card, the verifier asks the phone a narrow question, such as whether the holder is over 21, and receives a cryptographically signed yes or no from the issuing state. Nothing reusable needs to be stored, so a breach of the verifier yields no identity documents. This is data minimization in practice, and it answers the oversight gap the privacy researcher Zach Edwards raised in the article. It pairs with the AI control: minimization shrinks what can be stolen, and anomaly detection shrinks how long a thief has to steal what remains.</a:t>
+              <a:t>The current trend I connect to mitigation is the shift to mobile driver's licenses and selective disclosure, standardised in ISO/IEC 18013-5. TSA already accepts digital IDs at more than 250 airports and says it sees only the information it needs. Instead of photocopying a physical card, the verifier asks the phone a narrow question, such as whether the holder is over 21, and receives a cryptographically signed yes or no from the issuing state. Nothing reusable needs to be stored, so a breach of the verifier yields no identity documents. This is data minimization in practice, and it answers the oversight gap the privacy researcher Zach Edwards raised in the article. It pairs with the AI control: minimization shrinks what can be stolen, and anomaly detection shrinks how long a thief has to steal what remains.</a:t>
             </a:r>
           </a:p>
         </p:txBody>
@@ -928,7 +928,7 @@
           <a:lstStyle/>
           <a:p>
             <a:r>
-              <a:t>This case changed how I read my own Module 1 results. My detector scored well overall, but it evaluated single flows, and this attacker was patient enough to blend in flow by flow for over a year. As I work toward a career in security engineering, I want to design detectors that model behavior over time, and to push for architectures that store less sensitive data in the first place. The references are listed in APA format: the Krebs on Security article, the ISO standard for mobile driving licences, and Chapter 5 of Parisi's Hands-On Artificial Intelligence for Cybersecurity.</a:t>
+              <a:t>This case changed how I read my own Module 1 results. My detector scored well overall, but it evaluated single flows, and this attacker was patient enough to blend in flow by flow for over a year. As I work toward a career in security engineering, I want to design detectors that model behavior over time, and to push for architectures that store less sensitive data in the first place. The references are listed in APA format: the Krebs on Security article, the ISO standard for mobile driving licences, and Chapter 5 of Parisi's Hands-On Artificial Intelligence for Cybersecurity, and TSA's page on digital IDs.</a:t>
             </a:r>
           </a:p>
         </p:txBody>
@@ -6717,7 +6717,7 @@
                 </a:solidFill>
                 <a:latin typeface="Calibri"/>
               </a:rPr>
-              <a:t>HIGH</a:t>
+              <a:t>MODERATE</a:t>
             </a:r>
           </a:p>
         </p:txBody>
@@ -6759,7 +6759,7 @@
                 </a:solidFill>
                 <a:latin typeface="Calibri"/>
               </a:rPr>
-              <a:t>Forgery-grade IR/UV scans let criminals pass ID checks and open fraudulent credit, so a “verified” ID no longer proves who someone is.</a:t>
+              <a:t>No sign IDScan’s records were altered, but forgery-grade IR/UV scans let criminals pass other firms’ ID checks, so a “verified” ID no longer proves identity.</a:t>
             </a:r>
           </a:p>
         </p:txBody>
@@ -7915,58 +7915,14 @@
       </p:sp>
       <p:sp>
         <p:nvSpPr>
-          <p:cNvPr id="5" name="Rounded Rectangle 4"/>
-          <p:cNvSpPr/>
-          <p:nvPr/>
-        </p:nvSpPr>
-        <p:spPr>
-          <a:xfrm>
-            <a:off x="548640" y="1645920"/>
-            <a:ext cx="2514600" cy="1600200"/>
-          </a:xfrm>
-          <a:prstGeom prst="roundRect">
-            <a:avLst>
-              <a:gd name="adj" fmla="val 6000"/>
-            </a:avLst>
-          </a:prstGeom>
-          <a:solidFill>
-            <a:srgbClr val="F2F4F7"/>
-          </a:solidFill>
-          <a:ln>
-            <a:noFill/>
-          </a:ln>
-          <a:effectLst/>
-        </p:spPr>
-        <p:style>
-          <a:lnRef idx="1">
-            <a:schemeClr val="accent1"/>
-          </a:lnRef>
-          <a:fillRef idx="3">
-            <a:schemeClr val="accent1"/>
-          </a:fillRef>
-          <a:effectRef idx="2">
-            <a:schemeClr val="accent1"/>
-          </a:effectRef>
-          <a:fontRef idx="minor">
-            <a:schemeClr val="lt1"/>
-          </a:fontRef>
-        </p:style>
-        <p:txBody>
-          <a:bodyPr rtlCol="0" anchor="ctr"/>
-          <a:lstStyle/>
-          <a:p/>
-        </p:txBody>
-      </p:sp>
-      <p:sp>
-        <p:nvSpPr>
-          <p:cNvPr id="6" name="TextBox 5"/>
+          <p:cNvPr id="5" name="TextBox 4"/>
           <p:cNvSpPr txBox="1"/>
           <p:nvPr/>
         </p:nvSpPr>
         <p:spPr>
           <a:xfrm>
-            <a:off x="749808" y="1828800"/>
-            <a:ext cx="2112264" cy="320040"/>
+            <a:off x="548640" y="3337560"/>
+            <a:ext cx="11094415" cy="274320"/>
           </a:xfrm>
           <a:prstGeom prst="rect">
             <a:avLst/>
@@ -7988,15 +7944,68 @@
               </a:spcAft>
             </a:pPr>
             <a:r>
-              <a:rPr sz="1600" b="1" i="0">
-                <a:solidFill>
-                  <a:srgbClr val="0F1B2D"/>
-                </a:solidFill>
-                <a:latin typeface="Calibri"/>
-              </a:rPr>
-              <a:t>1  Collect</a:t>
-            </a:r>
-          </a:p>
+              <a:rPr sz="1250" b="1" i="0">
+                <a:solidFill>
+                  <a:srgbClr val="5B6472"/>
+                </a:solidFill>
+                <a:latin typeface="Calibri"/>
+              </a:rPr>
+              <a:t>Current industry practice:</a:t>
+            </a:r>
+            <a:r>
+              <a:rPr sz="1250" b="0" i="0">
+                <a:solidFill>
+                  <a:srgbClr val="5B6472"/>
+                </a:solidFill>
+                <a:latin typeface="Calibri"/>
+              </a:rPr>
+              <a:t> commercial UEBA and network detection and response (NDR) platforms flag exfiltration this way.</a:t>
+            </a:r>
+          </a:p>
+        </p:txBody>
+      </p:sp>
+      <p:sp>
+        <p:nvSpPr>
+          <p:cNvPr id="6" name="Rounded Rectangle 5"/>
+          <p:cNvSpPr/>
+          <p:nvPr/>
+        </p:nvSpPr>
+        <p:spPr>
+          <a:xfrm>
+            <a:off x="548640" y="1645920"/>
+            <a:ext cx="2514600" cy="1600200"/>
+          </a:xfrm>
+          <a:prstGeom prst="roundRect">
+            <a:avLst>
+              <a:gd name="adj" fmla="val 6000"/>
+            </a:avLst>
+          </a:prstGeom>
+          <a:solidFill>
+            <a:srgbClr val="F2F4F7"/>
+          </a:solidFill>
+          <a:ln>
+            <a:noFill/>
+          </a:ln>
+          <a:effectLst/>
+        </p:spPr>
+        <p:style>
+          <a:lnRef idx="1">
+            <a:schemeClr val="accent1"/>
+          </a:lnRef>
+          <a:fillRef idx="3">
+            <a:schemeClr val="accent1"/>
+          </a:fillRef>
+          <a:effectRef idx="2">
+            <a:schemeClr val="accent1"/>
+          </a:effectRef>
+          <a:fontRef idx="minor">
+            <a:schemeClr val="lt1"/>
+          </a:fontRef>
+        </p:style>
+        <p:txBody>
+          <a:bodyPr rtlCol="0" anchor="ctr"/>
+          <a:lstStyle/>
+          <a:p/>
         </p:txBody>
       </p:sp>
       <p:sp>
@@ -8007,8 +8016,8 @@
         </p:nvSpPr>
         <p:spPr>
           <a:xfrm>
-            <a:off x="749808" y="2212848"/>
-            <a:ext cx="2112264" cy="1005840"/>
+            <a:off x="749808" y="1828800"/>
+            <a:ext cx="2112264" cy="320040"/>
           </a:xfrm>
           <a:prstGeom prst="rect">
             <a:avLst/>
@@ -8030,114 +8039,27 @@
               </a:spcAft>
             </a:pPr>
             <a:r>
-              <a:rPr sz="1300" b="0" i="0">
-                <a:solidFill>
-                  <a:srgbClr val="1F2937"/>
-                </a:solidFill>
-                <a:latin typeface="Calibri"/>
-              </a:rPr>
-              <a:t>Flow and storage-access logs per service account</a:t>
-            </a:r>
-          </a:p>
-        </p:txBody>
-      </p:sp>
-      <p:sp>
-        <p:nvSpPr>
-          <p:cNvPr id="8" name="Right Arrow 7"/>
-          <p:cNvSpPr/>
-          <p:nvPr/>
-        </p:nvSpPr>
-        <p:spPr>
-          <a:xfrm>
-            <a:off x="3099816" y="2304288"/>
-            <a:ext cx="228600" cy="274320"/>
-          </a:xfrm>
-          <a:prstGeom prst="rightArrow">
-            <a:avLst/>
-          </a:prstGeom>
-          <a:solidFill>
-            <a:srgbClr val="1F5FAD"/>
-          </a:solidFill>
-          <a:ln>
-            <a:noFill/>
-          </a:ln>
-        </p:spPr>
-        <p:style>
-          <a:lnRef idx="1">
-            <a:schemeClr val="accent1"/>
-          </a:lnRef>
-          <a:fillRef idx="3">
-            <a:schemeClr val="accent1"/>
-          </a:fillRef>
-          <a:effectRef idx="2">
-            <a:schemeClr val="accent1"/>
-          </a:effectRef>
-          <a:fontRef idx="minor">
-            <a:schemeClr val="lt1"/>
-          </a:fontRef>
-        </p:style>
-        <p:txBody>
-          <a:bodyPr rtlCol="0" anchor="ctr"/>
-          <a:lstStyle/>
-          <a:p>
-            <a:pPr algn="ctr"/>
-          </a:p>
-        </p:txBody>
-      </p:sp>
-      <p:sp>
-        <p:nvSpPr>
-          <p:cNvPr id="9" name="Rounded Rectangle 8"/>
-          <p:cNvSpPr/>
-          <p:nvPr/>
-        </p:nvSpPr>
-        <p:spPr>
-          <a:xfrm>
-            <a:off x="3364992" y="1645920"/>
-            <a:ext cx="2514600" cy="1600200"/>
-          </a:xfrm>
-          <a:prstGeom prst="roundRect">
-            <a:avLst>
-              <a:gd name="adj" fmla="val 6000"/>
-            </a:avLst>
-          </a:prstGeom>
-          <a:solidFill>
-            <a:srgbClr val="F2F4F7"/>
-          </a:solidFill>
-          <a:ln>
-            <a:noFill/>
-          </a:ln>
-          <a:effectLst/>
-        </p:spPr>
-        <p:style>
-          <a:lnRef idx="1">
-            <a:schemeClr val="accent1"/>
-          </a:lnRef>
-          <a:fillRef idx="3">
-            <a:schemeClr val="accent1"/>
-          </a:fillRef>
-          <a:effectRef idx="2">
-            <a:schemeClr val="accent1"/>
-          </a:effectRef>
-          <a:fontRef idx="minor">
-            <a:schemeClr val="lt1"/>
-          </a:fontRef>
-        </p:style>
-        <p:txBody>
-          <a:bodyPr rtlCol="0" anchor="ctr"/>
-          <a:lstStyle/>
-          <a:p/>
-        </p:txBody>
-      </p:sp>
-      <p:sp>
-        <p:nvSpPr>
-          <p:cNvPr id="10" name="TextBox 9"/>
+              <a:rPr sz="1600" b="1" i="0">
+                <a:solidFill>
+                  <a:srgbClr val="0F1B2D"/>
+                </a:solidFill>
+                <a:latin typeface="Calibri"/>
+              </a:rPr>
+              <a:t>1  Collect</a:t>
+            </a:r>
+          </a:p>
+        </p:txBody>
+      </p:sp>
+      <p:sp>
+        <p:nvSpPr>
+          <p:cNvPr id="8" name="TextBox 7"/>
           <p:cNvSpPr txBox="1"/>
           <p:nvPr/>
         </p:nvSpPr>
         <p:spPr>
           <a:xfrm>
-            <a:off x="3566160" y="1828800"/>
-            <a:ext cx="2112264" cy="320040"/>
+            <a:off x="749808" y="2212848"/>
+            <a:ext cx="2112264" cy="1005840"/>
           </a:xfrm>
           <a:prstGeom prst="rect">
             <a:avLst/>
@@ -8159,15 +8081,102 @@
               </a:spcAft>
             </a:pPr>
             <a:r>
-              <a:rPr sz="1600" b="1" i="0">
-                <a:solidFill>
-                  <a:srgbClr val="0F1B2D"/>
-                </a:solidFill>
-                <a:latin typeface="Calibri"/>
-              </a:rPr>
-              <a:t>2  Learn normal</a:t>
-            </a:r>
-          </a:p>
+              <a:rPr sz="1300" b="0" i="0">
+                <a:solidFill>
+                  <a:srgbClr val="1F2937"/>
+                </a:solidFill>
+                <a:latin typeface="Calibri"/>
+              </a:rPr>
+              <a:t>Flow and storage-access logs per service account</a:t>
+            </a:r>
+          </a:p>
+        </p:txBody>
+      </p:sp>
+      <p:sp>
+        <p:nvSpPr>
+          <p:cNvPr id="9" name="Right Arrow 8"/>
+          <p:cNvSpPr/>
+          <p:nvPr/>
+        </p:nvSpPr>
+        <p:spPr>
+          <a:xfrm>
+            <a:off x="3099816" y="2304288"/>
+            <a:ext cx="228600" cy="274320"/>
+          </a:xfrm>
+          <a:prstGeom prst="rightArrow">
+            <a:avLst/>
+          </a:prstGeom>
+          <a:solidFill>
+            <a:srgbClr val="1F5FAD"/>
+          </a:solidFill>
+          <a:ln>
+            <a:noFill/>
+          </a:ln>
+        </p:spPr>
+        <p:style>
+          <a:lnRef idx="1">
+            <a:schemeClr val="accent1"/>
+          </a:lnRef>
+          <a:fillRef idx="3">
+            <a:schemeClr val="accent1"/>
+          </a:fillRef>
+          <a:effectRef idx="2">
+            <a:schemeClr val="accent1"/>
+          </a:effectRef>
+          <a:fontRef idx="minor">
+            <a:schemeClr val="lt1"/>
+          </a:fontRef>
+        </p:style>
+        <p:txBody>
+          <a:bodyPr rtlCol="0" anchor="ctr"/>
+          <a:lstStyle/>
+          <a:p>
+            <a:pPr algn="ctr"/>
+          </a:p>
+        </p:txBody>
+      </p:sp>
+      <p:sp>
+        <p:nvSpPr>
+          <p:cNvPr id="10" name="Rounded Rectangle 9"/>
+          <p:cNvSpPr/>
+          <p:nvPr/>
+        </p:nvSpPr>
+        <p:spPr>
+          <a:xfrm>
+            <a:off x="3364992" y="1645920"/>
+            <a:ext cx="2514600" cy="1600200"/>
+          </a:xfrm>
+          <a:prstGeom prst="roundRect">
+            <a:avLst>
+              <a:gd name="adj" fmla="val 6000"/>
+            </a:avLst>
+          </a:prstGeom>
+          <a:solidFill>
+            <a:srgbClr val="F2F4F7"/>
+          </a:solidFill>
+          <a:ln>
+            <a:noFill/>
+          </a:ln>
+          <a:effectLst/>
+        </p:spPr>
+        <p:style>
+          <a:lnRef idx="1">
+            <a:schemeClr val="accent1"/>
+          </a:lnRef>
+          <a:fillRef idx="3">
+            <a:schemeClr val="accent1"/>
+          </a:fillRef>
+          <a:effectRef idx="2">
+            <a:schemeClr val="accent1"/>
+          </a:effectRef>
+          <a:fontRef idx="minor">
+            <a:schemeClr val="lt1"/>
+          </a:fontRef>
+        </p:style>
+        <p:txBody>
+          <a:bodyPr rtlCol="0" anchor="ctr"/>
+          <a:lstStyle/>
+          <a:p/>
         </p:txBody>
       </p:sp>
       <p:sp>
@@ -8178,8 +8187,8 @@
         </p:nvSpPr>
         <p:spPr>
           <a:xfrm>
-            <a:off x="3566160" y="2212848"/>
-            <a:ext cx="2112264" cy="1005840"/>
+            <a:off x="3566160" y="1828800"/>
+            <a:ext cx="2112264" cy="320040"/>
           </a:xfrm>
           <a:prstGeom prst="rect">
             <a:avLst/>
@@ -8201,114 +8210,27 @@
               </a:spcAft>
             </a:pPr>
             <a:r>
-              <a:rPr sz="1300" b="0" i="0">
-                <a:solidFill>
-                  <a:srgbClr val="1F2937"/>
-                </a:solidFill>
-                <a:latin typeface="Calibri"/>
-              </a:rPr>
-              <a:t>Baseline bytes out, records read, destinations, hour</a:t>
-            </a:r>
-          </a:p>
-        </p:txBody>
-      </p:sp>
-      <p:sp>
-        <p:nvSpPr>
-          <p:cNvPr id="12" name="Right Arrow 11"/>
-          <p:cNvSpPr/>
-          <p:nvPr/>
-        </p:nvSpPr>
-        <p:spPr>
-          <a:xfrm>
-            <a:off x="5916168" y="2304288"/>
-            <a:ext cx="228600" cy="274320"/>
-          </a:xfrm>
-          <a:prstGeom prst="rightArrow">
-            <a:avLst/>
-          </a:prstGeom>
-          <a:solidFill>
-            <a:srgbClr val="1F5FAD"/>
-          </a:solidFill>
-          <a:ln>
-            <a:noFill/>
-          </a:ln>
-        </p:spPr>
-        <p:style>
-          <a:lnRef idx="1">
-            <a:schemeClr val="accent1"/>
-          </a:lnRef>
-          <a:fillRef idx="3">
-            <a:schemeClr val="accent1"/>
-          </a:fillRef>
-          <a:effectRef idx="2">
-            <a:schemeClr val="accent1"/>
-          </a:effectRef>
-          <a:fontRef idx="minor">
-            <a:schemeClr val="lt1"/>
-          </a:fontRef>
-        </p:style>
-        <p:txBody>
-          <a:bodyPr rtlCol="0" anchor="ctr"/>
-          <a:lstStyle/>
-          <a:p>
-            <a:pPr algn="ctr"/>
-          </a:p>
-        </p:txBody>
-      </p:sp>
-      <p:sp>
-        <p:nvSpPr>
-          <p:cNvPr id="13" name="Rounded Rectangle 12"/>
-          <p:cNvSpPr/>
-          <p:nvPr/>
-        </p:nvSpPr>
-        <p:spPr>
-          <a:xfrm>
-            <a:off x="6181344" y="1645920"/>
-            <a:ext cx="2514600" cy="1600200"/>
-          </a:xfrm>
-          <a:prstGeom prst="roundRect">
-            <a:avLst>
-              <a:gd name="adj" fmla="val 6000"/>
-            </a:avLst>
-          </a:prstGeom>
-          <a:solidFill>
-            <a:srgbClr val="0F1B2D"/>
-          </a:solidFill>
-          <a:ln>
-            <a:noFill/>
-          </a:ln>
-          <a:effectLst/>
-        </p:spPr>
-        <p:style>
-          <a:lnRef idx="1">
-            <a:schemeClr val="accent1"/>
-          </a:lnRef>
-          <a:fillRef idx="3">
-            <a:schemeClr val="accent1"/>
-          </a:fillRef>
-          <a:effectRef idx="2">
-            <a:schemeClr val="accent1"/>
-          </a:effectRef>
-          <a:fontRef idx="minor">
-            <a:schemeClr val="lt1"/>
-          </a:fontRef>
-        </p:style>
-        <p:txBody>
-          <a:bodyPr rtlCol="0" anchor="ctr"/>
-          <a:lstStyle/>
-          <a:p/>
-        </p:txBody>
-      </p:sp>
-      <p:sp>
-        <p:nvSpPr>
-          <p:cNvPr id="14" name="TextBox 13"/>
+              <a:rPr sz="1600" b="1" i="0">
+                <a:solidFill>
+                  <a:srgbClr val="0F1B2D"/>
+                </a:solidFill>
+                <a:latin typeface="Calibri"/>
+              </a:rPr>
+              <a:t>2  Learn normal</a:t>
+            </a:r>
+          </a:p>
+        </p:txBody>
+      </p:sp>
+      <p:sp>
+        <p:nvSpPr>
+          <p:cNvPr id="12" name="TextBox 11"/>
           <p:cNvSpPr txBox="1"/>
           <p:nvPr/>
         </p:nvSpPr>
         <p:spPr>
           <a:xfrm>
-            <a:off x="6382512" y="1828800"/>
-            <a:ext cx="2112264" cy="320040"/>
+            <a:off x="3566160" y="2212848"/>
+            <a:ext cx="2112264" cy="1005840"/>
           </a:xfrm>
           <a:prstGeom prst="rect">
             <a:avLst/>
@@ -8330,15 +8252,102 @@
               </a:spcAft>
             </a:pPr>
             <a:r>
-              <a:rPr sz="1600" b="1" i="0">
-                <a:solidFill>
-                  <a:srgbClr val="FFFFFF"/>
-                </a:solidFill>
-                <a:latin typeface="Calibri"/>
-              </a:rPr>
-              <a:t>3  Score</a:t>
-            </a:r>
-          </a:p>
+              <a:rPr sz="1300" b="0" i="0">
+                <a:solidFill>
+                  <a:srgbClr val="1F2937"/>
+                </a:solidFill>
+                <a:latin typeface="Calibri"/>
+              </a:rPr>
+              <a:t>Baseline bytes out, records read, destinations, hour</a:t>
+            </a:r>
+          </a:p>
+        </p:txBody>
+      </p:sp>
+      <p:sp>
+        <p:nvSpPr>
+          <p:cNvPr id="13" name="Right Arrow 12"/>
+          <p:cNvSpPr/>
+          <p:nvPr/>
+        </p:nvSpPr>
+        <p:spPr>
+          <a:xfrm>
+            <a:off x="5916168" y="2304288"/>
+            <a:ext cx="228600" cy="274320"/>
+          </a:xfrm>
+          <a:prstGeom prst="rightArrow">
+            <a:avLst/>
+          </a:prstGeom>
+          <a:solidFill>
+            <a:srgbClr val="1F5FAD"/>
+          </a:solidFill>
+          <a:ln>
+            <a:noFill/>
+          </a:ln>
+        </p:spPr>
+        <p:style>
+          <a:lnRef idx="1">
+            <a:schemeClr val="accent1"/>
+          </a:lnRef>
+          <a:fillRef idx="3">
+            <a:schemeClr val="accent1"/>
+          </a:fillRef>
+          <a:effectRef idx="2">
+            <a:schemeClr val="accent1"/>
+          </a:effectRef>
+          <a:fontRef idx="minor">
+            <a:schemeClr val="lt1"/>
+          </a:fontRef>
+        </p:style>
+        <p:txBody>
+          <a:bodyPr rtlCol="0" anchor="ctr"/>
+          <a:lstStyle/>
+          <a:p>
+            <a:pPr algn="ctr"/>
+          </a:p>
+        </p:txBody>
+      </p:sp>
+      <p:sp>
+        <p:nvSpPr>
+          <p:cNvPr id="14" name="Rounded Rectangle 13"/>
+          <p:cNvSpPr/>
+          <p:nvPr/>
+        </p:nvSpPr>
+        <p:spPr>
+          <a:xfrm>
+            <a:off x="6181344" y="1645920"/>
+            <a:ext cx="2514600" cy="1600200"/>
+          </a:xfrm>
+          <a:prstGeom prst="roundRect">
+            <a:avLst>
+              <a:gd name="adj" fmla="val 6000"/>
+            </a:avLst>
+          </a:prstGeom>
+          <a:solidFill>
+            <a:srgbClr val="0F1B2D"/>
+          </a:solidFill>
+          <a:ln>
+            <a:noFill/>
+          </a:ln>
+          <a:effectLst/>
+        </p:spPr>
+        <p:style>
+          <a:lnRef idx="1">
+            <a:schemeClr val="accent1"/>
+          </a:lnRef>
+          <a:fillRef idx="3">
+            <a:schemeClr val="accent1"/>
+          </a:fillRef>
+          <a:effectRef idx="2">
+            <a:schemeClr val="accent1"/>
+          </a:effectRef>
+          <a:fontRef idx="minor">
+            <a:schemeClr val="lt1"/>
+          </a:fontRef>
+        </p:style>
+        <p:txBody>
+          <a:bodyPr rtlCol="0" anchor="ctr"/>
+          <a:lstStyle/>
+          <a:p/>
         </p:txBody>
       </p:sp>
       <p:sp>
@@ -8349,8 +8358,8 @@
         </p:nvSpPr>
         <p:spPr>
           <a:xfrm>
-            <a:off x="6382512" y="2212848"/>
-            <a:ext cx="2112264" cy="1005840"/>
+            <a:off x="6382512" y="1828800"/>
+            <a:ext cx="2112264" cy="320040"/>
           </a:xfrm>
           <a:prstGeom prst="rect">
             <a:avLst/>
@@ -8372,114 +8381,27 @@
               </a:spcAft>
             </a:pPr>
             <a:r>
-              <a:rPr sz="1300" b="0" i="0">
+              <a:rPr sz="1600" b="1" i="0">
                 <a:solidFill>
                   <a:srgbClr val="FFFFFF"/>
                 </a:solidFill>
                 <a:latin typeface="Calibri"/>
               </a:rPr>
-              <a:t>Gaussian / GMM density: low p(x) = anomaly (Parisi, 2019, ch. 5)</a:t>
-            </a:r>
-          </a:p>
-        </p:txBody>
-      </p:sp>
-      <p:sp>
-        <p:nvSpPr>
-          <p:cNvPr id="16" name="Right Arrow 15"/>
-          <p:cNvSpPr/>
-          <p:nvPr/>
-        </p:nvSpPr>
-        <p:spPr>
-          <a:xfrm>
-            <a:off x="8732519" y="2304288"/>
-            <a:ext cx="228600" cy="274320"/>
-          </a:xfrm>
-          <a:prstGeom prst="rightArrow">
-            <a:avLst/>
-          </a:prstGeom>
-          <a:solidFill>
-            <a:srgbClr val="1F5FAD"/>
-          </a:solidFill>
-          <a:ln>
-            <a:noFill/>
-          </a:ln>
-        </p:spPr>
-        <p:style>
-          <a:lnRef idx="1">
-            <a:schemeClr val="accent1"/>
-          </a:lnRef>
-          <a:fillRef idx="3">
-            <a:schemeClr val="accent1"/>
-          </a:fillRef>
-          <a:effectRef idx="2">
-            <a:schemeClr val="accent1"/>
-          </a:effectRef>
-          <a:fontRef idx="minor">
-            <a:schemeClr val="lt1"/>
-          </a:fontRef>
-        </p:style>
-        <p:txBody>
-          <a:bodyPr rtlCol="0" anchor="ctr"/>
-          <a:lstStyle/>
-          <a:p>
-            <a:pPr algn="ctr"/>
-          </a:p>
-        </p:txBody>
-      </p:sp>
-      <p:sp>
-        <p:nvSpPr>
-          <p:cNvPr id="17" name="Rounded Rectangle 16"/>
-          <p:cNvSpPr/>
-          <p:nvPr/>
-        </p:nvSpPr>
-        <p:spPr>
-          <a:xfrm>
-            <a:off x="8997696" y="1645920"/>
-            <a:ext cx="2514600" cy="1600200"/>
-          </a:xfrm>
-          <a:prstGeom prst="roundRect">
-            <a:avLst>
-              <a:gd name="adj" fmla="val 6000"/>
-            </a:avLst>
-          </a:prstGeom>
-          <a:solidFill>
-            <a:srgbClr val="F2F4F7"/>
-          </a:solidFill>
-          <a:ln>
-            <a:noFill/>
-          </a:ln>
-          <a:effectLst/>
-        </p:spPr>
-        <p:style>
-          <a:lnRef idx="1">
-            <a:schemeClr val="accent1"/>
-          </a:lnRef>
-          <a:fillRef idx="3">
-            <a:schemeClr val="accent1"/>
-          </a:fillRef>
-          <a:effectRef idx="2">
-            <a:schemeClr val="accent1"/>
-          </a:effectRef>
-          <a:fontRef idx="minor">
-            <a:schemeClr val="lt1"/>
-          </a:fontRef>
-        </p:style>
-        <p:txBody>
-          <a:bodyPr rtlCol="0" anchor="ctr"/>
-          <a:lstStyle/>
-          <a:p/>
-        </p:txBody>
-      </p:sp>
-      <p:sp>
-        <p:nvSpPr>
-          <p:cNvPr id="18" name="TextBox 17"/>
+              <a:t>3  Score</a:t>
+            </a:r>
+          </a:p>
+        </p:txBody>
+      </p:sp>
+      <p:sp>
+        <p:nvSpPr>
+          <p:cNvPr id="16" name="TextBox 15"/>
           <p:cNvSpPr txBox="1"/>
           <p:nvPr/>
         </p:nvSpPr>
         <p:spPr>
           <a:xfrm>
-            <a:off x="9198864" y="1828800"/>
-            <a:ext cx="2112264" cy="320040"/>
+            <a:off x="6382512" y="2212848"/>
+            <a:ext cx="2112264" cy="1005840"/>
           </a:xfrm>
           <a:prstGeom prst="rect">
             <a:avLst/>
@@ -8501,15 +8423,102 @@
               </a:spcAft>
             </a:pPr>
             <a:r>
-              <a:rPr sz="1600" b="1" i="0">
-                <a:solidFill>
-                  <a:srgbClr val="0F1B2D"/>
-                </a:solidFill>
-                <a:latin typeface="Calibri"/>
-              </a:rPr>
-              <a:t>4  Respond</a:t>
-            </a:r>
-          </a:p>
+              <a:rPr sz="1300" b="0" i="0">
+                <a:solidFill>
+                  <a:srgbClr val="FFFFFF"/>
+                </a:solidFill>
+                <a:latin typeface="Calibri"/>
+              </a:rPr>
+              <a:t>Gaussian / GMM density: low p(x) = anomaly (Parisi, 2019, ch. 5)</a:t>
+            </a:r>
+          </a:p>
+        </p:txBody>
+      </p:sp>
+      <p:sp>
+        <p:nvSpPr>
+          <p:cNvPr id="17" name="Right Arrow 16"/>
+          <p:cNvSpPr/>
+          <p:nvPr/>
+        </p:nvSpPr>
+        <p:spPr>
+          <a:xfrm>
+            <a:off x="8732519" y="2304288"/>
+            <a:ext cx="228600" cy="274320"/>
+          </a:xfrm>
+          <a:prstGeom prst="rightArrow">
+            <a:avLst/>
+          </a:prstGeom>
+          <a:solidFill>
+            <a:srgbClr val="1F5FAD"/>
+          </a:solidFill>
+          <a:ln>
+            <a:noFill/>
+          </a:ln>
+        </p:spPr>
+        <p:style>
+          <a:lnRef idx="1">
+            <a:schemeClr val="accent1"/>
+          </a:lnRef>
+          <a:fillRef idx="3">
+            <a:schemeClr val="accent1"/>
+          </a:fillRef>
+          <a:effectRef idx="2">
+            <a:schemeClr val="accent1"/>
+          </a:effectRef>
+          <a:fontRef idx="minor">
+            <a:schemeClr val="lt1"/>
+          </a:fontRef>
+        </p:style>
+        <p:txBody>
+          <a:bodyPr rtlCol="0" anchor="ctr"/>
+          <a:lstStyle/>
+          <a:p>
+            <a:pPr algn="ctr"/>
+          </a:p>
+        </p:txBody>
+      </p:sp>
+      <p:sp>
+        <p:nvSpPr>
+          <p:cNvPr id="18" name="Rounded Rectangle 17"/>
+          <p:cNvSpPr/>
+          <p:nvPr/>
+        </p:nvSpPr>
+        <p:spPr>
+          <a:xfrm>
+            <a:off x="8997696" y="1645920"/>
+            <a:ext cx="2514600" cy="1600200"/>
+          </a:xfrm>
+          <a:prstGeom prst="roundRect">
+            <a:avLst>
+              <a:gd name="adj" fmla="val 6000"/>
+            </a:avLst>
+          </a:prstGeom>
+          <a:solidFill>
+            <a:srgbClr val="F2F4F7"/>
+          </a:solidFill>
+          <a:ln>
+            <a:noFill/>
+          </a:ln>
+          <a:effectLst/>
+        </p:spPr>
+        <p:style>
+          <a:lnRef idx="1">
+            <a:schemeClr val="accent1"/>
+          </a:lnRef>
+          <a:fillRef idx="3">
+            <a:schemeClr val="accent1"/>
+          </a:fillRef>
+          <a:effectRef idx="2">
+            <a:schemeClr val="accent1"/>
+          </a:effectRef>
+          <a:fontRef idx="minor">
+            <a:schemeClr val="lt1"/>
+          </a:fontRef>
+        </p:style>
+        <p:txBody>
+          <a:bodyPr rtlCol="0" anchor="ctr"/>
+          <a:lstStyle/>
+          <a:p/>
         </p:txBody>
       </p:sp>
       <p:sp>
@@ -8520,8 +8529,8 @@
         </p:nvSpPr>
         <p:spPr>
           <a:xfrm>
-            <a:off x="9198864" y="2212848"/>
-            <a:ext cx="2112264" cy="1005840"/>
+            <a:off x="9198864" y="1828800"/>
+            <a:ext cx="2112264" cy="320040"/>
           </a:xfrm>
           <a:prstGeom prst="rect">
             <a:avLst/>
@@ -8543,69 +8552,27 @@
               </a:spcAft>
             </a:pPr>
             <a:r>
-              <a:rPr sz="1300" b="0" i="0">
-                <a:solidFill>
-                  <a:srgbClr val="1F2937"/>
-                </a:solidFill>
-                <a:latin typeface="Calibri"/>
-              </a:rPr>
-              <a:t>Alert, revoke the token, block the destination</a:t>
-            </a:r>
-          </a:p>
-        </p:txBody>
-      </p:sp>
-      <p:sp>
-        <p:nvSpPr>
-          <p:cNvPr id="20" name="Rectangle 19"/>
-          <p:cNvSpPr/>
-          <p:nvPr/>
-        </p:nvSpPr>
-        <p:spPr>
-          <a:xfrm>
-            <a:off x="548640" y="3657600"/>
-            <a:ext cx="73152" cy="1325880"/>
-          </a:xfrm>
-          <a:prstGeom prst="rect">
-            <a:avLst/>
-          </a:prstGeom>
-          <a:solidFill>
-            <a:srgbClr val="1F5FAD"/>
-          </a:solidFill>
-          <a:ln>
-            <a:noFill/>
-          </a:ln>
-          <a:effectLst/>
-        </p:spPr>
-        <p:style>
-          <a:lnRef idx="1">
-            <a:schemeClr val="accent1"/>
-          </a:lnRef>
-          <a:fillRef idx="3">
-            <a:schemeClr val="accent1"/>
-          </a:fillRef>
-          <a:effectRef idx="2">
-            <a:schemeClr val="accent1"/>
-          </a:effectRef>
-          <a:fontRef idx="minor">
-            <a:schemeClr val="lt1"/>
-          </a:fontRef>
-        </p:style>
-        <p:txBody>
-          <a:bodyPr rtlCol="0" anchor="ctr"/>
-          <a:lstStyle/>
-          <a:p/>
-        </p:txBody>
-      </p:sp>
-      <p:sp>
-        <p:nvSpPr>
-          <p:cNvPr id="21" name="TextBox 20"/>
+              <a:rPr sz="1600" b="1" i="0">
+                <a:solidFill>
+                  <a:srgbClr val="0F1B2D"/>
+                </a:solidFill>
+                <a:latin typeface="Calibri"/>
+              </a:rPr>
+              <a:t>4  Respond</a:t>
+            </a:r>
+          </a:p>
+        </p:txBody>
+      </p:sp>
+      <p:sp>
+        <p:nvSpPr>
+          <p:cNvPr id="20" name="TextBox 19"/>
           <p:cNvSpPr txBox="1"/>
           <p:nvPr/>
         </p:nvSpPr>
         <p:spPr>
           <a:xfrm>
-            <a:off x="822959" y="3657600"/>
-            <a:ext cx="5120640" cy="274320"/>
+            <a:off x="9198864" y="2212848"/>
+            <a:ext cx="2112264" cy="1005840"/>
           </a:xfrm>
           <a:prstGeom prst="rect">
             <a:avLst/>
@@ -8627,15 +8594,57 @@
               </a:spcAft>
             </a:pPr>
             <a:r>
-              <a:rPr sz="1200" b="1" i="0">
-                <a:solidFill>
-                  <a:srgbClr val="1F5FAD"/>
-                </a:solidFill>
-                <a:latin typeface="Calibri"/>
-              </a:rPr>
-              <a:t>APPLIED TO THIS BREACH</a:t>
-            </a:r>
-          </a:p>
+              <a:rPr sz="1300" b="0" i="0">
+                <a:solidFill>
+                  <a:srgbClr val="1F2937"/>
+                </a:solidFill>
+                <a:latin typeface="Calibri"/>
+              </a:rPr>
+              <a:t>Alert, revoke the token, block the destination</a:t>
+            </a:r>
+          </a:p>
+        </p:txBody>
+      </p:sp>
+      <p:sp>
+        <p:nvSpPr>
+          <p:cNvPr id="21" name="Rectangle 20"/>
+          <p:cNvSpPr/>
+          <p:nvPr/>
+        </p:nvSpPr>
+        <p:spPr>
+          <a:xfrm>
+            <a:off x="548640" y="3886200"/>
+            <a:ext cx="73152" cy="1325880"/>
+          </a:xfrm>
+          <a:prstGeom prst="rect">
+            <a:avLst/>
+          </a:prstGeom>
+          <a:solidFill>
+            <a:srgbClr val="1F5FAD"/>
+          </a:solidFill>
+          <a:ln>
+            <a:noFill/>
+          </a:ln>
+          <a:effectLst/>
+        </p:spPr>
+        <p:style>
+          <a:lnRef idx="1">
+            <a:schemeClr val="accent1"/>
+          </a:lnRef>
+          <a:fillRef idx="3">
+            <a:schemeClr val="accent1"/>
+          </a:fillRef>
+          <a:effectRef idx="2">
+            <a:schemeClr val="accent1"/>
+          </a:effectRef>
+          <a:fontRef idx="minor">
+            <a:schemeClr val="lt1"/>
+          </a:fontRef>
+        </p:style>
+        <p:txBody>
+          <a:bodyPr rtlCol="0" anchor="ctr"/>
+          <a:lstStyle/>
+          <a:p/>
         </p:txBody>
       </p:sp>
       <p:sp>
@@ -8646,8 +8655,8 @@
         </p:nvSpPr>
         <p:spPr>
           <a:xfrm>
-            <a:off x="822959" y="4023360"/>
-            <a:ext cx="5120640" cy="1828800"/>
+            <a:off x="822959" y="3886200"/>
+            <a:ext cx="5120640" cy="274320"/>
           </a:xfrm>
           <a:prstGeom prst="rect">
             <a:avLst/>
@@ -8669,87 +8678,27 @@
               </a:spcAft>
             </a:pPr>
             <a:r>
-              <a:rPr sz="1500" b="0" i="0">
-                <a:solidFill>
-                  <a:srgbClr val="1F2937"/>
-                </a:solidFill>
-                <a:latin typeface="Calibri"/>
-              </a:rPr>
-              <a:t>An account that normally reads few images starts sending ~400K records a day to a new host. That falls far outside its baseline, so it is </a:t>
-            </a:r>
-            <a:r>
-              <a:rPr sz="1500" b="1" i="0">
-                <a:solidFill>
-                  <a:srgbClr val="1F2937"/>
-                </a:solidFill>
-                <a:latin typeface="Calibri"/>
-              </a:rPr>
-              <a:t>cut off within hours, not after a year</a:t>
-            </a:r>
-            <a:r>
-              <a:rPr sz="1500" b="0" i="0">
-                <a:solidFill>
-                  <a:srgbClr val="1F2937"/>
-                </a:solidFill>
-                <a:latin typeface="Calibri"/>
-              </a:rPr>
-              <a:t>.</a:t>
-            </a:r>
-          </a:p>
-        </p:txBody>
-      </p:sp>
-      <p:sp>
-        <p:nvSpPr>
-          <p:cNvPr id="23" name="Rectangle 22"/>
-          <p:cNvSpPr/>
-          <p:nvPr/>
-        </p:nvSpPr>
-        <p:spPr>
-          <a:xfrm>
-            <a:off x="6217920" y="3657600"/>
-            <a:ext cx="73152" cy="1325880"/>
-          </a:xfrm>
-          <a:prstGeom prst="rect">
-            <a:avLst/>
-          </a:prstGeom>
-          <a:solidFill>
-            <a:srgbClr val="C0392B"/>
-          </a:solidFill>
-          <a:ln>
-            <a:noFill/>
-          </a:ln>
-          <a:effectLst/>
-        </p:spPr>
-        <p:style>
-          <a:lnRef idx="1">
-            <a:schemeClr val="accent1"/>
-          </a:lnRef>
-          <a:fillRef idx="3">
-            <a:schemeClr val="accent1"/>
-          </a:fillRef>
-          <a:effectRef idx="2">
-            <a:schemeClr val="accent1"/>
-          </a:effectRef>
-          <a:fontRef idx="minor">
-            <a:schemeClr val="lt1"/>
-          </a:fontRef>
-        </p:style>
-        <p:txBody>
-          <a:bodyPr rtlCol="0" anchor="ctr"/>
-          <a:lstStyle/>
-          <a:p/>
-        </p:txBody>
-      </p:sp>
-      <p:sp>
-        <p:nvSpPr>
-          <p:cNvPr id="24" name="TextBox 23"/>
+              <a:rPr sz="1200" b="1" i="0">
+                <a:solidFill>
+                  <a:srgbClr val="1F5FAD"/>
+                </a:solidFill>
+                <a:latin typeface="Calibri"/>
+              </a:rPr>
+              <a:t>APPLIED TO THIS BREACH</a:t>
+            </a:r>
+          </a:p>
+        </p:txBody>
+      </p:sp>
+      <p:sp>
+        <p:nvSpPr>
+          <p:cNvPr id="23" name="TextBox 22"/>
           <p:cNvSpPr txBox="1"/>
           <p:nvPr/>
         </p:nvSpPr>
         <p:spPr>
           <a:xfrm>
-            <a:off x="6492240" y="3657600"/>
-            <a:ext cx="5120640" cy="274320"/>
+            <a:off x="822959" y="4251960"/>
+            <a:ext cx="5120640" cy="1828800"/>
           </a:xfrm>
           <a:prstGeom prst="rect">
             <a:avLst/>
@@ -8771,15 +8720,75 @@
               </a:spcAft>
             </a:pPr>
             <a:r>
-              <a:rPr sz="1200" b="1" i="0">
-                <a:solidFill>
-                  <a:srgbClr val="C0392B"/>
-                </a:solidFill>
-                <a:latin typeface="Calibri"/>
-              </a:rPr>
-              <a:t>LESSON FROM MY MODULE 1 LAB</a:t>
-            </a:r>
-          </a:p>
+              <a:rPr sz="1500" b="0" i="0">
+                <a:solidFill>
+                  <a:srgbClr val="1F2937"/>
+                </a:solidFill>
+                <a:latin typeface="Calibri"/>
+              </a:rPr>
+              <a:t>An account that normally reads few images starts sending ~400K records a day to a new host. That falls far outside its baseline, so it is </a:t>
+            </a:r>
+            <a:r>
+              <a:rPr sz="1500" b="1" i="0">
+                <a:solidFill>
+                  <a:srgbClr val="1F2937"/>
+                </a:solidFill>
+                <a:latin typeface="Calibri"/>
+              </a:rPr>
+              <a:t>cut off within hours, not after a year</a:t>
+            </a:r>
+            <a:r>
+              <a:rPr sz="1500" b="0" i="0">
+                <a:solidFill>
+                  <a:srgbClr val="1F2937"/>
+                </a:solidFill>
+                <a:latin typeface="Calibri"/>
+              </a:rPr>
+              <a:t>.</a:t>
+            </a:r>
+          </a:p>
+        </p:txBody>
+      </p:sp>
+      <p:sp>
+        <p:nvSpPr>
+          <p:cNvPr id="24" name="Rectangle 23"/>
+          <p:cNvSpPr/>
+          <p:nvPr/>
+        </p:nvSpPr>
+        <p:spPr>
+          <a:xfrm>
+            <a:off x="6217920" y="3886200"/>
+            <a:ext cx="73152" cy="1325880"/>
+          </a:xfrm>
+          <a:prstGeom prst="rect">
+            <a:avLst/>
+          </a:prstGeom>
+          <a:solidFill>
+            <a:srgbClr val="C0392B"/>
+          </a:solidFill>
+          <a:ln>
+            <a:noFill/>
+          </a:ln>
+          <a:effectLst/>
+        </p:spPr>
+        <p:style>
+          <a:lnRef idx="1">
+            <a:schemeClr val="accent1"/>
+          </a:lnRef>
+          <a:fillRef idx="3">
+            <a:schemeClr val="accent1"/>
+          </a:fillRef>
+          <a:effectRef idx="2">
+            <a:schemeClr val="accent1"/>
+          </a:effectRef>
+          <a:fontRef idx="minor">
+            <a:schemeClr val="lt1"/>
+          </a:fontRef>
+        </p:style>
+        <p:txBody>
+          <a:bodyPr rtlCol="0" anchor="ctr"/>
+          <a:lstStyle/>
+          <a:p/>
         </p:txBody>
       </p:sp>
       <p:sp>
@@ -8790,8 +8799,8 @@
         </p:nvSpPr>
         <p:spPr>
           <a:xfrm>
-            <a:off x="6492240" y="4023360"/>
-            <a:ext cx="5120640" cy="1828800"/>
+            <a:off x="6492240" y="3886200"/>
+            <a:ext cx="5120640" cy="274320"/>
           </a:xfrm>
           <a:prstGeom prst="rect">
             <a:avLst/>
@@ -8813,6 +8822,48 @@
               </a:spcAft>
             </a:pPr>
             <a:r>
+              <a:rPr sz="1200" b="1" i="0">
+                <a:solidFill>
+                  <a:srgbClr val="C0392B"/>
+                </a:solidFill>
+                <a:latin typeface="Calibri"/>
+              </a:rPr>
+              <a:t>LESSON FROM MY MODULE 1 LAB</a:t>
+            </a:r>
+          </a:p>
+        </p:txBody>
+      </p:sp>
+      <p:sp>
+        <p:nvSpPr>
+          <p:cNvPr id="26" name="TextBox 25"/>
+          <p:cNvSpPr txBox="1"/>
+          <p:nvPr/>
+        </p:nvSpPr>
+        <p:spPr>
+          <a:xfrm>
+            <a:off x="6492240" y="4251960"/>
+            <a:ext cx="5120640" cy="1828800"/>
+          </a:xfrm>
+          <a:prstGeom prst="rect">
+            <a:avLst/>
+          </a:prstGeom>
+          <a:noFill/>
+        </p:spPr>
+        <p:txBody>
+          <a:bodyPr wrap="square" lIns="0" rIns="0" tIns="0" bIns="0" anchor="t">
+            <a:spAutoFit/>
+          </a:bodyPr>
+          <a:lstStyle/>
+          <a:p>
+            <a:pPr algn="l">
+              <a:lnSpc>
+                <a:spcPct val="110000"/>
+              </a:lnSpc>
+              <a:spcAft>
+                <a:spcPts val="0"/>
+              </a:spcAft>
+            </a:pPr>
+            <a:r>
               <a:rPr sz="1500" b="0" i="0">
                 <a:solidFill>
                   <a:srgbClr val="1F2937"/>
@@ -8862,7 +8913,7 @@
       </p:sp>
       <p:cxnSp>
         <p:nvCxnSpPr>
-          <p:cNvPr id="26" name="Connector 25"/>
+          <p:cNvPr id="27" name="Connector 26"/>
           <p:cNvCxnSpPr/>
           <p:nvPr/>
         </p:nvCxnSpPr>
@@ -8897,7 +8948,7 @@
       </p:cxnSp>
       <p:sp>
         <p:nvSpPr>
-          <p:cNvPr id="27" name="TextBox 26"/>
+          <p:cNvPr id="28" name="TextBox 27"/>
           <p:cNvSpPr txBox="1"/>
           <p:nvPr/>
         </p:nvSpPr>
@@ -8939,7 +8990,7 @@
       </p:sp>
       <p:sp>
         <p:nvSpPr>
-          <p:cNvPr id="28" name="TextBox 27"/>
+          <p:cNvPr id="29" name="TextBox 28"/>
           <p:cNvSpPr txBox="1"/>
           <p:nvPr/>
         </p:nvSpPr>
@@ -9854,7 +9905,7 @@
                 </a:solidFill>
                 <a:latin typeface="Calibri"/>
               </a:rPr>
-              <a:t> mobile driver’s licenses (ISO/IEC 18013-5, 2021), now accepted by more U.S. states and TSA checkpoints.</a:t>
+              <a:t> mobile driver’s licenses (ISO/IEC 18013-5). TSA accepts digital IDs at 250+ airports and “sees only the necessary information.”</a:t>
             </a:r>
           </a:p>
           <a:p>
@@ -10039,7 +10090,7 @@
                 </a:solidFill>
                 <a:latin typeface="Calibri"/>
               </a:rPr>
-              <a:t>Sources: International Organization for Standardization (2021); Krebs (2026).</a:t>
+              <a:t>Sources: International Organization for Standardization (2021); Krebs (2026); Transportation Security Administration (n.d.).</a:t>
             </a:r>
           </a:p>
         </p:txBody>
@@ -10492,11 +10543,11 @@
                 <a:spcPct val="105000"/>
               </a:lnSpc>
               <a:spcAft>
-                <a:spcPts val="1000"/>
+                <a:spcPts val="800"/>
               </a:spcAft>
             </a:pPr>
             <a:r>
-              <a:rPr sz="1200" b="0" i="0">
+              <a:rPr sz="1150" b="0" i="0">
                 <a:solidFill>
                   <a:srgbClr val="1F2937"/>
                 </a:solidFill>
@@ -10505,7 +10556,7 @@
               <a:t>Krebs, B. (2026, September 1). FBI probes service selling 153M+ drivers licenses. </a:t>
             </a:r>
             <a:r>
-              <a:rPr sz="1200" b="0" i="1">
+              <a:rPr sz="1150" b="0" i="1">
                 <a:solidFill>
                   <a:srgbClr val="1F2937"/>
                 </a:solidFill>
@@ -10514,7 +10565,7 @@
               <a:t>Krebs on Security</a:t>
             </a:r>
             <a:r>
-              <a:rPr sz="1200" b="0" i="0">
+              <a:rPr sz="1150" b="0" i="0">
                 <a:solidFill>
                   <a:srgbClr val="1F2937"/>
                 </a:solidFill>
@@ -10529,11 +10580,11 @@
                 <a:spcPct val="105000"/>
               </a:lnSpc>
               <a:spcAft>
-                <a:spcPts val="1000"/>
+                <a:spcPts val="800"/>
               </a:spcAft>
             </a:pPr>
             <a:r>
-              <a:rPr sz="1200" b="0" i="0">
+              <a:rPr sz="1150" b="0" i="0">
                 <a:solidFill>
                   <a:srgbClr val="1F2937"/>
                 </a:solidFill>
@@ -10542,7 +10593,7 @@
               <a:t>International Organization for Standardization. (2021). </a:t>
             </a:r>
             <a:r>
-              <a:rPr sz="1200" b="0" i="1">
+              <a:rPr sz="1150" b="0" i="1">
                 <a:solidFill>
                   <a:srgbClr val="1F2937"/>
                 </a:solidFill>
@@ -10551,7 +10602,7 @@
               <a:t>Personal identification: ISO-compliant driving licence. Part 5: Mobile driving licence (mDL) application</a:t>
             </a:r>
             <a:r>
-              <a:rPr sz="1200" b="0" i="0">
+              <a:rPr sz="1150" b="0" i="0">
                 <a:solidFill>
                   <a:srgbClr val="1F2937"/>
                 </a:solidFill>
@@ -10566,11 +10617,11 @@
                 <a:spcPct val="105000"/>
               </a:lnSpc>
               <a:spcAft>
-                <a:spcPts val="1000"/>
+                <a:spcPts val="800"/>
               </a:spcAft>
             </a:pPr>
             <a:r>
-              <a:rPr sz="1200" b="0" i="0">
+              <a:rPr sz="1150" b="0" i="0">
                 <a:solidFill>
                   <a:srgbClr val="1F2937"/>
                 </a:solidFill>
@@ -10579,7 +10630,7 @@
               <a:t>Parisi, A. (2019). </a:t>
             </a:r>
             <a:r>
-              <a:rPr sz="1200" b="0" i="1">
+              <a:rPr sz="1150" b="0" i="1">
                 <a:solidFill>
                   <a:srgbClr val="1F2937"/>
                 </a:solidFill>
@@ -10588,13 +10639,50 @@
               <a:t>Hands-on artificial intelligence for cybersecurity: Implement smart AI systems for preventing cyber attacks and detecting threats and network anomalies</a:t>
             </a:r>
             <a:r>
-              <a:rPr sz="1200" b="0" i="0">
+              <a:rPr sz="1150" b="0" i="0">
                 <a:solidFill>
                   <a:srgbClr val="1F2937"/>
                 </a:solidFill>
                 <a:latin typeface="Calibri"/>
               </a:rPr>
               <a:t>. Packt Publishing.</a:t>
+            </a:r>
+          </a:p>
+          <a:p>
+            <a:pPr algn="l" marL="365760" indent="-365760">
+              <a:lnSpc>
+                <a:spcPct val="105000"/>
+              </a:lnSpc>
+              <a:spcAft>
+                <a:spcPts val="800"/>
+              </a:spcAft>
+            </a:pPr>
+            <a:r>
+              <a:rPr sz="1150" b="0" i="0">
+                <a:solidFill>
+                  <a:srgbClr val="1F2937"/>
+                </a:solidFill>
+                <a:latin typeface="Calibri"/>
+              </a:rPr>
+              <a:t>Transportation Security Administration. (n.d.). </a:t>
+            </a:r>
+            <a:r>
+              <a:rPr sz="1150" b="0" i="1">
+                <a:solidFill>
+                  <a:srgbClr val="1F2937"/>
+                </a:solidFill>
+                <a:latin typeface="Calibri"/>
+              </a:rPr>
+              <a:t>Digital identity and facial comparison technology</a:t>
+            </a:r>
+            <a:r>
+              <a:rPr sz="1150" b="0" i="0">
+                <a:solidFill>
+                  <a:srgbClr val="1F2937"/>
+                </a:solidFill>
+                <a:latin typeface="Calibri"/>
+              </a:rPr>
+              <a:t>. Retrieved September 27, 2026, from https://www.tsa.gov/digital-id</a:t>
             </a:r>
           </a:p>
         </p:txBody>

</xml_diff>

<commit_message>
CIA deck: qualify breach attribution, mDL retention caveat, detection timing
Co-Authored-By: Claude Opus 5.5 <noreply@anthropic.com>
</commit_message>
<xml_diff>
--- a/module-02-cia-triad-analysis/Ruthvik_Nath_Bandari_Module2_CIA_Triad_Analysis.pptx
+++ b/module-02-cia-triad-analysis/Ruthvik_Nath_Bandari_Module2_CIA_Triad_Analysis.pptx
@@ -508,7 +508,7 @@
           <a:lstStyle/>
           <a:p>
             <a:r>
-              <a:t>This presentation analyses a breach reported by Brian Krebs on September 1, 2026. A dark-web service called Nexus was selling scans of more than 153 million U.S. and Canadian driver's licenses, and the evidence pointed to IDScan.net, an identity verification vendor. I will summarise the incident, map it to the CIA triad, explain why confidentiality was hit hardest, and recommend an AI-based control from Chapter 5 together with a current industry trend that would have reduced the damage.</a:t>
+              <a:t>This presentation analyses a breach reported by Brian Krebs on September 1, 2026. A dark-web service called Nexus advertised scans of more than 153 million U.S. and Canadian driver's licenses. Krebs traced the samples he could verify to IDScan.net, an identity verification vendor, which later confirmed a breach; the article does not establish that every advertised record came from that one company. I will summarise the incident, map it to the CIA triad, explain why confidentiality was hit hardest, and recommend an AI-based control from Chapter 5 together with a current industry trend that would have reduced the damage.</a:t>
             </a:r>
           </a:p>
         </p:txBody>
@@ -578,7 +578,7 @@
           <a:lstStyle/>
           <a:p>
             <a:r>
-              <a:t>Who: IDScan.net verifies IDs for Hertz, Target, FedEx and more than a thousand cannabis dispensaries, running over 21 million verifications a month. What: the Nexus service listed over 153 million driver's licenses, more than 10 million ID cards, three million travel documents and 579,000 medical cards, often with infrared and ultraviolet images. When: Krebs matched image timestamps to trips as early as June 2025; Nexus was advertised on August 31, 2026, the FBI opened an inquiry on September 1, and IDScan confirmed unauthorized access on September 8. How: the attackers claimed continuous exfiltration for over a year, and the record count grew by about 400,000 in a single day. The threat is data theft for identity fraud; the impact includes identity and credit fraud, IDScan's notification and credit-protection costs, an FBI investigation, and exposure of senior officials such as the U.S. Defense Secretary.</a:t>
+              <a:t>Who: IDScan.net verifies IDs for Hertz, Target, FedEx and more than a thousand cannabis dispensaries, running over 21 million verifications a month. What: the Nexus service advertised over 153 million driver's licenses, more than 10 million ID cards, three million travel documents and 579,000 medical cards, often with infrared and ultraviolet images. When: Krebs matched image timestamps to trips as early as June 2025; Nexus was advertised on August 31, 2026, the FBI opened an inquiry on September 1, and IDScan confirmed unauthorized access on September 8. Krebs verified the link to IDScan through nine people whose records matched their trips; the full 153 million figure is the sellers' own claim. How: the attackers claimed continuous exfiltration for over a year, and the record count grew by about 400,000 in a single day. The threat is data theft for identity fraud; the impact includes identity and credit fraud, IDScan's notification and credit-protection costs, an FBI investigation, and exposure of senior officials such as the U.S. Defense Secretary.</a:t>
             </a:r>
           </a:p>
         </p:txBody>
@@ -648,7 +648,7 @@
           <a:lstStyle/>
           <a:p>
             <a:r>
-              <a:t>This diagram maps the attack onto the triad. The attack vector is the long-running exfiltration in the centre. Confidentiality is severe: more than 153 million identity images were copied and sold. Integrity is moderate: Krebs reports no evidence that IDScan's stored records were altered, so the harm is downstream. The stolen scans include the infrared and ultraviolet images that verifiers check, so criminals can make convincing forgeries and open fraudulent accounts elsewhere, which undermines the trust that a verified ID proves identity. Availability is low: Krebs reports no outage of IDScan's service, but there is indirect loss, because victims must freeze their credit and business clients may have to pause or repeat verification while the vendor investigates.</a:t>
+              <a:t>This diagram maps the attack onto the triad. The attack vector is the long-running exfiltration in the centre. Confidentiality is severe: Nexus advertised more than 153 million identity images, and Krebs verified that real, matching records were for sale. Integrity is moderate: Krebs reports no evidence that IDScan's stored records were altered, so the harm is downstream. The stolen scans include the infrared and ultraviolet images that verifiers check, so criminals can make convincing forgeries and open fraudulent accounts elsewhere, which undermines the trust that a verified ID proves identity. Availability is low: Krebs reports no outage of IDScan's service, but there is indirect loss, because victims must freeze their credit and business clients may have to pause or repeat verification while the vendor investigates.</a:t>
             </a:r>
           </a:p>
         </p:txBody>
@@ -788,7 +788,7 @@
           <a:lstStyle/>
           <a:p>
             <a:r>
-              <a:t>My recommended control is AI-based egress anomaly detection, which applies Chapter 5 of Parisi directly. The detector learns what normal outbound activity looks like for each service account, using features such as bytes sent, records read, destination and time of day, and fits a Gaussian or Gaussian mixture density. Activity with very low probability is flagged, and a SOAR playbook can revoke the token and block the destination. In this breach, an account suddenly moving hundreds of thousands of license images a day would stand out and be stopped in hours. My Module 1 lab adds a caveat: my benign-only mixture model scored ROC-AUC 0.966, but it missed attacks that look normal one flow at a time. So the detector must aggregate per account over days, which is how commercial UEBA and network detection platforms work today. This makes the control realistic for current industry practice.</a:t>
+              <a:t>My recommended control is AI-based egress anomaly detection, which applies Chapter 5 of Parisi directly. The detector learns what normal outbound activity looks like for each service account, using features such as bytes sent, records read, destination and time of day, and fits a Gaussian or Gaussian mixture density. Activity with very low probability is flagged, and a SOAR playbook can revoke the token and block the destination. In this breach, an account suddenly moving hundreds of thousands of license images a day would likely stand out. Whether it is stopped within hours depends on having logs for the image store, well-tuned thresholds and an automated response, so I present that as a plausible outcome rather than a guarantee. My Module 1 lab adds a caveat: my benign-only mixture model scored ROC-AUC 0.966, but it missed attacks that look normal one flow at a time. So the detector must aggregate per account over days, which is how commercial UEBA and network detection platforms work today. This makes the control realistic for current industry practice.</a:t>
             </a:r>
           </a:p>
         </p:txBody>
@@ -858,7 +858,7 @@
           <a:lstStyle/>
           <a:p>
             <a:r>
-              <a:t>The current trend I connect to mitigation is the shift to mobile driver's licenses and selective disclosure, standardised in ISO/IEC 18013-5. TSA already accepts digital IDs at more than 250 airports and says it sees only the information it needs. Instead of photocopying a physical card, the verifier asks the phone a narrow question, such as whether the holder is over 21, and receives a cryptographically signed yes or no from the issuing state. Nothing reusable needs to be stored, so a breach of the verifier yields no identity documents. This is data minimization in practice, and it answers the oversight gap the privacy researcher Zach Edwards raised in the article. It pairs with the AI control: minimization shrinks what can be stolen, and anomaly detection shrinks how long a thief has to steal what remains.</a:t>
+              <a:t>The current trend I connect to mitigation is the shift to mobile driver's licenses and selective disclosure, standardised in ISO/IEC 18013-5. TSA already accepts digital IDs at more than 250 airports and says it sees only the information it needs. Instead of photocopying a physical card, the verifier asks the phone a narrow question, such as whether the holder is over 21, and receives a cryptographically signed yes or no from the issuing state. That reduces what the verifier receives, but the benefit depends on implementation: ISO/IEC 18013-5 leaves requirements for storing mDL data out of scope, so verifiers still need retention limits for a breach to yield less. This is data minimization in practice, and it answers the oversight gap the privacy researcher Zach Edwards raised in the article. It pairs with the AI control: minimization shrinks what can be stolen, and anomaly detection shrinks how long a thief has to steal what remains.</a:t>
             </a:r>
           </a:p>
         </p:txBody>
@@ -4026,8 +4026,8 @@
         </p:nvSpPr>
         <p:spPr>
           <a:xfrm>
-            <a:off x="548640" y="1691640"/>
-            <a:ext cx="10515600" cy="1645920"/>
+            <a:off x="548640" y="1645920"/>
+            <a:ext cx="10515600" cy="1554480"/>
           </a:xfrm>
           <a:prstGeom prst="rect">
             <a:avLst/>
@@ -4045,17 +4045,36 @@
                 <a:spcPct val="100000"/>
               </a:lnSpc>
               <a:spcAft>
-                <a:spcPts val="600"/>
+                <a:spcPts val="0"/>
               </a:spcAft>
             </a:pPr>
             <a:r>
-              <a:rPr sz="4800" b="1" i="0">
+              <a:rPr sz="4600" b="1" i="0">
                 <a:solidFill>
                   <a:srgbClr val="FFFFFF"/>
                 </a:solidFill>
                 <a:latin typeface="Calibri"/>
               </a:rPr>
-              <a:t>153 Million Driver’s Licenses for Sale</a:t>
+              <a:t>153 Million Driver’s Licenses</a:t>
+            </a:r>
+          </a:p>
+          <a:p>
+            <a:pPr algn="l">
+              <a:lnSpc>
+                <a:spcPct val="100000"/>
+              </a:lnSpc>
+              <a:spcAft>
+                <a:spcPts val="0"/>
+              </a:spcAft>
+            </a:pPr>
+            <a:r>
+              <a:rPr sz="4600" b="1" i="0">
+                <a:solidFill>
+                  <a:srgbClr val="FFFFFF"/>
+                </a:solidFill>
+                <a:latin typeface="Calibri"/>
+              </a:rPr>
+              <a:t>Advertised for Sale</a:t>
             </a:r>
           </a:p>
         </p:txBody>
@@ -4068,8 +4087,8 @@
         </p:nvSpPr>
         <p:spPr>
           <a:xfrm>
-            <a:off x="548640" y="2651760"/>
-            <a:ext cx="10515600" cy="914400"/>
+            <a:off x="548640" y="3246120"/>
+            <a:ext cx="11155680" cy="914400"/>
           </a:xfrm>
           <a:prstGeom prst="rect">
             <a:avLst/>
@@ -4091,13 +4110,13 @@
               </a:spcAft>
             </a:pPr>
             <a:r>
-              <a:rPr sz="2400" b="0" i="0">
+              <a:rPr sz="2200" b="0" i="0">
                 <a:solidFill>
                   <a:srgbClr val="C9D3E0"/>
                 </a:solidFill>
                 <a:latin typeface="Calibri"/>
               </a:rPr>
-              <a:t>A CIA triad analysis of the IDScan.net breach behind the Nexus identity-theft service</a:t>
+              <a:t>A CIA triad analysis of the Nexus ID-theft service and the confirmed IDScan.net breach</a:t>
             </a:r>
           </a:p>
         </p:txBody>
@@ -4110,7 +4129,7 @@
         </p:nvSpPr>
         <p:spPr>
           <a:xfrm>
-            <a:off x="548640" y="4343400"/>
+            <a:off x="548640" y="4434840"/>
             <a:ext cx="7315200" cy="1097280"/>
           </a:xfrm>
           <a:prstGeom prst="rect">
@@ -4485,12 +4504,39 @@
               </a:spcAft>
             </a:pPr>
             <a:r>
+              <a:rPr sz="1450" b="0" i="0">
+                <a:solidFill>
+                  <a:srgbClr val="1F2937"/>
+                </a:solidFill>
+                <a:latin typeface="Calibri"/>
+              </a:rPr>
+              <a:t>Nexus advertised </a:t>
+            </a:r>
+            <a:r>
               <a:rPr sz="1450" b="1" i="0">
                 <a:solidFill>
                   <a:srgbClr val="1F2937"/>
                 </a:solidFill>
                 <a:latin typeface="Calibri"/>
               </a:rPr>
+              <a:t>153M+</a:t>
+            </a:r>
+            <a:r>
+              <a:rPr sz="1450" b="0" i="0">
+                <a:solidFill>
+                  <a:srgbClr val="1F2937"/>
+                </a:solidFill>
+                <a:latin typeface="Calibri"/>
+              </a:rPr>
+              <a:t> licenses. Krebs traced verified samples to </a:t>
+            </a:r>
+            <a:r>
+              <a:rPr sz="1450" b="1" i="0">
+                <a:solidFill>
+                  <a:srgbClr val="1F2937"/>
+                </a:solidFill>
+                <a:latin typeface="Calibri"/>
+              </a:rPr>
               <a:t>IDScan.net</a:t>
             </a:r>
             <a:r>
@@ -4500,25 +4546,7 @@
                 </a:solidFill>
                 <a:latin typeface="Calibri"/>
               </a:rPr>
-              <a:t>, an ID-verification vendor for Hertz, retailers and 1,000+ dispensaries. Victims: </a:t>
-            </a:r>
-            <a:r>
-              <a:rPr sz="1450" b="1" i="0">
-                <a:solidFill>
-                  <a:srgbClr val="1F2937"/>
-                </a:solidFill>
-                <a:latin typeface="Calibri"/>
-              </a:rPr>
-              <a:t>153M+</a:t>
-            </a:r>
-            <a:r>
-              <a:rPr sz="1450" b="0" i="0">
-                <a:solidFill>
-                  <a:srgbClr val="1F2937"/>
-                </a:solidFill>
-                <a:latin typeface="Calibri"/>
-              </a:rPr>
-              <a:t> U.S. and Canadian license holders.</a:t>
+              <a:t>, an ID-verification vendor for Hertz, retailers and 1,000+ dispensaries.</a:t>
             </a:r>
           </a:p>
         </p:txBody>
@@ -5709,7 +5737,7 @@
                 </a:solidFill>
                 <a:latin typeface="Calibri"/>
               </a:rPr>
-              <a:t>IDScan.net confirms the breach</a:t>
+              <a:t>IDScan.net confirms unauthorized access</a:t>
             </a:r>
           </a:p>
         </p:txBody>
@@ -6547,7 +6575,7 @@
                 </a:solidFill>
                 <a:latin typeface="Calibri"/>
               </a:rPr>
-              <a:t>153M+ license images copied and sold, including those of the U.S. Defense Secretary and an FBI assistant director.</a:t>
+              <a:t>Nexus advertised 153M+ license images; records for sale include the U.S. Defense Secretary’s and an FBI assistant director’s.</a:t>
             </a:r>
           </a:p>
         </p:txBody>
@@ -7362,7 +7390,7 @@
                 </a:solidFill>
                 <a:latin typeface="Calibri"/>
               </a:rPr>
-              <a:t>driver’s license records exposed</a:t>
+              <a:t>license records advertised; Krebs verified a sample</a:t>
             </a:r>
           </a:p>
         </p:txBody>
@@ -7490,7 +7518,7 @@
                 </a:solidFill>
                 <a:latin typeface="Calibri"/>
               </a:rPr>
-              <a:t>of exfiltration before it was detected</a:t>
+              <a:t>of exfiltration claimed; scans date to June 2025</a:t>
             </a:r>
           </a:p>
         </p:txBody>
@@ -8726,7 +8754,7 @@
                 </a:solidFill>
                 <a:latin typeface="Calibri"/>
               </a:rPr>
-              <a:t>An account that normally reads few images starts sending ~400K records a day to a new host. That falls far outside its baseline, so it is </a:t>
+              <a:t>An account that normally reads few images starts sending ~400K records a day to a new host. That falls far outside its baseline, so it </a:t>
             </a:r>
             <a:r>
               <a:rPr sz="1500" b="1" i="0">
@@ -8735,7 +8763,7 @@
                 </a:solidFill>
                 <a:latin typeface="Calibri"/>
               </a:rPr>
-              <a:t>cut off within hours, not after a year</a:t>
+              <a:t>could be flagged within hours</a:t>
             </a:r>
             <a:r>
               <a:rPr sz="1500" b="0" i="0">
@@ -8744,7 +8772,7 @@
                 </a:solidFill>
                 <a:latin typeface="Calibri"/>
               </a:rPr>
-              <a:t>.</a:t>
+              <a:t>, given log coverage, tuned thresholds and automated response.</a:t>
             </a:r>
           </a:p>
         </p:txBody>
@@ -9169,7 +9197,7 @@
                 </a:solidFill>
                 <a:latin typeface="Calibri"/>
               </a:rPr>
-              <a:t>Trend: mobile IDs shrink what there is to steal</a:t>
+              <a:t>Trend: mobile IDs can shrink what there is to steal</a:t>
             </a:r>
           </a:p>
         </p:txBody>
@@ -9849,7 +9877,7 @@
                 </a:solidFill>
                 <a:latin typeface="Calibri"/>
               </a:rPr>
-              <a:t>A breach leaks a signed answer, not an identity</a:t>
+              <a:t>Less to leak, if the verifier does not retain data</a:t>
             </a:r>
           </a:p>
         </p:txBody>
@@ -9938,7 +9966,7 @@
                 </a:solidFill>
                 <a:latin typeface="Calibri"/>
               </a:rPr>
-              <a:t> verifiers never hold an image, so a breach like IDScan’s yields nothing reusable.</a:t>
+              <a:t> verifiers can receive only what they need. The benefit depends on retention: ISO/IEC 18013-5 leaves storage rules out of scope.</a:t>
             </a:r>
           </a:p>
           <a:p>

</xml_diff>

<commit_message>
CIA deck: rewrite reflection around course themes
Co-Authored-By: Claude Opus 5.5 <noreply@anthropic.com>
</commit_message>
<xml_diff>
--- a/module-02-cia-triad-analysis/Ruthvik_Nath_Bandari_Module2_CIA_Triad_Analysis.pptx
+++ b/module-02-cia-triad-analysis/Ruthvik_Nath_Bandari_Module2_CIA_Triad_Analysis.pptx
@@ -928,7 +928,7 @@
           <a:lstStyle/>
           <a:p>
             <a:r>
-              <a:t>This case changed how I read my own Module 1 results. My detector scored well overall, but it evaluated single flows, and this attacker was patient enough to blend in flow by flow for over a year. As I work toward a career in security engineering, I want to design detectors that model behavior over time, and to push for architectures that store less sensitive data in the first place. The references are listed in APA format: the Krebs on Security article, the ISO standard for mobile driving licences, and Chapter 5 of Parisi's Hands-On Artificial Intelligence for Cybersecurity, and TSA's page on digital IDs.</a:t>
+              <a:t>This case exposed a blind spot in my own Module 1 detector. It scored well overall, but it judged single flows, and this attacker was patient enough to blend in flow by flow for over a year. The habit I most want to carry forward is interrogating a model until its limits are explicit, because a strong score does not prove broad protection. The cipher lab in this module taught me that structure leaks through encryption; this breach showed that stored data leaks too, so sometimes the best control is simply keeping less of it. In my future security engineering work, I want to build detectors that model behavior over time, and keep a named analyst accountable for high-impact automated responses. The references are listed in APA format: the Krebs on Security article, the ISO standard for mobile driving licences, Chapter 5 of Parisi's Hands-On Artificial Intelligence for Cybersecurity, and TSA's page on digital IDs.</a:t>
             </a:r>
           </a:p>
         </p:txBody>
@@ -10432,7 +10432,16 @@
                 </a:solidFill>
                 <a:latin typeface="Calibri"/>
               </a:rPr>
-              <a:t>This case changed how I read my Module 1 detector: a strong score is not enough when an attacker is patient enough to look normal one event at a time.</a:t>
+              <a:t>My Module 1 detector scored well, but this breach exposes its blind spot: a patient attacker who looks normal one flow at a time. </a:t>
+            </a:r>
+            <a:r>
+              <a:rPr sz="1500" b="1" i="0">
+                <a:solidFill>
+                  <a:srgbClr val="1F2937"/>
+                </a:solidFill>
+                <a:latin typeface="Calibri"/>
+              </a:rPr>
+              <a:t>A model’s limits matter as much as its score.</a:t>
             </a:r>
           </a:p>
           <a:p>
@@ -10451,25 +10460,7 @@
                 </a:solidFill>
                 <a:latin typeface="Calibri"/>
               </a:rPr>
-              <a:t>In security engineering, I want to build detectors that model </a:t>
-            </a:r>
-            <a:r>
-              <a:rPr sz="1500" b="1" i="0">
-                <a:solidFill>
-                  <a:srgbClr val="1F2937"/>
-                </a:solidFill>
-                <a:latin typeface="Calibri"/>
-              </a:rPr>
-              <a:t>behavior over time</a:t>
-            </a:r>
-            <a:r>
-              <a:rPr sz="1500" b="0" i="0">
-                <a:solidFill>
-                  <a:srgbClr val="1F2937"/>
-                </a:solidFill>
-                <a:latin typeface="Calibri"/>
-              </a:rPr>
-              <a:t> and to argue for storing less data.</a:t>
+              <a:t>The cipher lab showed me that patterns leak. Here, stored data leaked. Sometimes the strongest control is keeping less.</a:t>
             </a:r>
           </a:p>
           <a:p>
@@ -10482,13 +10473,22 @@
               </a:spcAft>
             </a:pPr>
             <a:r>
+              <a:rPr sz="1500" b="0" i="0">
+                <a:solidFill>
+                  <a:srgbClr val="1F2937"/>
+                </a:solidFill>
+                <a:latin typeface="Calibri"/>
+              </a:rPr>
+              <a:t>As a future security engineer, I want to build detectors that track </a:t>
+            </a:r>
+            <a:r>
               <a:rPr sz="1500" b="1" i="0">
                 <a:solidFill>
                   <a:srgbClr val="1F2937"/>
                 </a:solidFill>
                 <a:latin typeface="Calibri"/>
               </a:rPr>
-              <a:t>Three questions I now ask:</a:t>
+              <a:t>behavior over time</a:t>
             </a:r>
             <a:r>
               <a:rPr sz="1500" b="0" i="0">
@@ -10497,7 +10497,7 @@
                 </a:solidFill>
                 <a:latin typeface="Calibri"/>
               </a:rPr>
-              <a:t> What do we store? How fast would we notice it leaving? How quickly can we cut it off?</a:t>
+              <a:t>, with a named analyst approving high-impact responses.</a:t>
             </a:r>
           </a:p>
         </p:txBody>

</xml_diff>